<commit_message>
chore(preview): CROX outputs regeneres
</commit_message>
<xml_diff>
--- a/preview/CROX/CROX_pitchbook.pptx
+++ b/preview/CROX/CROX_pitchbook.pptx
@@ -3341,51 +3341,8 @@
         </p:nvSpPr>
         <p:spPr>
           <a:xfrm>
-            <a:off x="457200" y="2720232"/>
-            <a:ext cx="8229600" cy="475200"/>
-          </a:xfrm>
-          <a:prstGeom prst="rect">
-            <a:avLst/>
-          </a:prstGeom>
-          <a:solidFill>
-            <a:srgbClr val="EAF4EF"/>
-          </a:solidFill>
-          <a:ln>
-            <a:noFill/>
-          </a:ln>
-        </p:spPr>
-        <p:style>
-          <a:lnRef idx="1">
-            <a:schemeClr val="accent1"/>
-          </a:lnRef>
-          <a:fillRef idx="3">
-            <a:schemeClr val="accent1"/>
-          </a:fillRef>
-          <a:effectRef idx="2">
-            <a:schemeClr val="accent1"/>
-          </a:effectRef>
-          <a:fontRef idx="minor">
-            <a:schemeClr val="lt1"/>
-          </a:fontRef>
-        </p:style>
-        <p:txBody>
-          <a:bodyPr rtlCol="0" anchor="ctr"/>
-          <a:lstStyle/>
-          <a:p>
-            <a:pPr algn="ctr"/>
-          </a:p>
-        </p:txBody>
-      </p:sp>
-      <p:sp>
-        <p:nvSpPr>
-          <p:cNvPr id="9" name="Rectangle 8"/>
-          <p:cNvSpPr/>
-          <p:nvPr/>
-        </p:nvSpPr>
-        <p:spPr>
-          <a:xfrm>
-            <a:off x="457200" y="2720232"/>
-            <a:ext cx="46800" cy="475200"/>
+            <a:off x="2771999" y="2720232"/>
+            <a:ext cx="3600000" cy="432000"/>
           </a:xfrm>
           <a:prstGeom prst="rect">
             <a:avLst/>
@@ -3421,14 +3378,14 @@
       </p:sp>
       <p:sp>
         <p:nvSpPr>
-          <p:cNvPr id="10" name="TextBox 9"/>
+          <p:cNvPr id="9" name="TextBox 8"/>
           <p:cNvSpPr txBox="1"/>
           <p:nvPr/>
         </p:nvSpPr>
         <p:spPr>
           <a:xfrm>
-            <a:off x="576000" y="2738232"/>
-            <a:ext cx="8063999" cy="439200"/>
+            <a:off x="2826000" y="2738232"/>
+            <a:ext cx="3491999" cy="395999"/>
           </a:xfrm>
           <a:prstGeom prst="rect">
             <a:avLst/>
@@ -3445,7 +3402,7 @@
             <a:r>
               <a:rPr sz="900" b="1" i="0">
                 <a:solidFill>
-                  <a:srgbClr val="1A7A4A"/>
+                  <a:srgbClr val="FFFFFF"/>
                 </a:solidFill>
                 <a:latin typeface="Calibri"/>
               </a:rPr>
@@ -3456,7 +3413,7 @@
       </p:sp>
       <p:sp>
         <p:nvSpPr>
-          <p:cNvPr id="11" name="Rectangle 10"/>
+          <p:cNvPr id="10" name="Rectangle 9"/>
           <p:cNvSpPr/>
           <p:nvPr/>
         </p:nvSpPr>
@@ -3499,7 +3456,7 @@
       </p:sp>
       <p:sp>
         <p:nvSpPr>
-          <p:cNvPr id="12" name="TextBox 11"/>
+          <p:cNvPr id="11" name="TextBox 10"/>
           <p:cNvSpPr txBox="1"/>
           <p:nvPr/>
         </p:nvSpPr>
@@ -3534,7 +3491,7 @@
       </p:sp>
       <p:sp>
         <p:nvSpPr>
-          <p:cNvPr id="13" name="TextBox 12"/>
+          <p:cNvPr id="12" name="TextBox 11"/>
           <p:cNvSpPr txBox="1"/>
           <p:nvPr/>
         </p:nvSpPr>
@@ -6138,7 +6095,7 @@
                 </a:solidFill>
                 <a:latin typeface="Calibri"/>
               </a:rPr>
-              <a:t>Les marges brutes sont passées de 52,3% en 2022 à 58,3% en 2025 grâce à une meilleure gestion des coûts de matières premières et une optimisation de la chaîne logistique. L'EBITDA margin a chuté à 5,9% en 2025 en raison de coûts fixes non absorbés, mais devrait retrouver 28% en 2026 avec la reprise du volume. La durabilité de ces marges dépend de la capacité à maintenir les prix premium et à limiter les promotions.</a:t>
+              <a:t>Les marges brutes ont progressé de 52.3% (2022) à 58.8% (2024) grâce à l'optimisation des coûts de production et au mix produit premium. L'EBITDA margin a chuté à 5.9% en 2025 en raison de coûts fixes élevés et d'investissements agressifs en marketing. Cette compression est temporaire : la durabilité des marges brutes et la reprise de l'EBITDA margin à 20% d'ici 2027 suggèrent un potentiel de re-rating.</a:t>
             </a:r>
           </a:p>
         </p:txBody>
@@ -9480,7 +9437,7 @@
                 </a:solidFill>
                 <a:latin typeface="Calibri"/>
               </a:rPr>
-              <a:t>Avec un WACC de 10,9% et une TGR de 2,5%, le prix implicite DCF est de 98$ (base), soit un upside de 17% vs le cours actuel. Cet écart suggère une sous-valorisation structurelle liée à la reprise des marges et à la génération de cash, mais dépend de l'exécution opérationnelle et de la gestion des coûts logistiques.</a:t>
+              <a:t>Avec un WACC de 10.9% et une TGR de 2.5%, le prix implicite DCF est de 98.5$ (base), soit un upside de 18% vs le cours actuel. La prime actuelle reflète une sous-valorisation structurelle liée à la compression temporaire des marges, mais un catalyseur comme une amélioration des marges EBITDA à 20% en 2027 débloquerait la valeur.</a:t>
             </a:r>
           </a:p>
         </p:txBody>
@@ -10544,7 +10501,7 @@
                           </a:solidFill>
                           <a:latin typeface="Calibri"/>
                         </a:rPr>
-                        <a:t>15,2</a:t>
+                        <a:t>14,2</a:t>
                       </a:r>
                     </a:p>
                   </a:txBody>
@@ -10567,7 +10524,7 @@
                           </a:solidFill>
                           <a:latin typeface="Calibri"/>
                         </a:rPr>
-                        <a:t>18,7x</a:t>
+                        <a:t>18,5x</a:t>
                       </a:r>
                     </a:p>
                   </a:txBody>
@@ -10590,7 +10547,7 @@
                           </a:solidFill>
                           <a:latin typeface="Calibri"/>
                         </a:rPr>
-                        <a:t>3,1x</a:t>
+                        <a:t>2,8x</a:t>
                       </a:r>
                     </a:p>
                   </a:txBody>
@@ -10613,7 +10570,7 @@
                           </a:solidFill>
                           <a:latin typeface="Calibri"/>
                         </a:rPr>
-                        <a:t>22,5x</a:t>
+                        <a:t>22,0x</a:t>
                       </a:r>
                     </a:p>
                   </a:txBody>
@@ -10636,7 +10593,7 @@
                           </a:solidFill>
                           <a:latin typeface="Calibri"/>
                         </a:rPr>
-                        <a:t>54,0 %</a:t>
+                        <a:t>55,0 %</a:t>
                       </a:r>
                     </a:p>
                   </a:txBody>
@@ -10659,7 +10616,7 @@
                           </a:solidFill>
                           <a:latin typeface="Calibri"/>
                         </a:rPr>
-                        <a:t>18,0 %</a:t>
+                        <a:t>15,0 %</a:t>
                       </a:r>
                     </a:p>
                   </a:txBody>
@@ -10730,7 +10687,7 @@
                           </a:solidFill>
                           <a:latin typeface="Calibri"/>
                         </a:rPr>
-                        <a:t>3,8</a:t>
+                        <a:t>3,1</a:t>
                       </a:r>
                     </a:p>
                   </a:txBody>
@@ -10753,7 +10710,7 @@
                           </a:solidFill>
                           <a:latin typeface="Calibri"/>
                         </a:rPr>
-                        <a:t>12,4x</a:t>
+                        <a:t>12,0x</a:t>
                       </a:r>
                     </a:p>
                   </a:txBody>
@@ -10799,7 +10756,7 @@
                           </a:solidFill>
                           <a:latin typeface="Calibri"/>
                         </a:rPr>
-                        <a:t>15,2x</a:t>
+                        <a:t>15,0x</a:t>
                       </a:r>
                     </a:p>
                   </a:txBody>
@@ -10845,7 +10802,7 @@
                           </a:solidFill>
                           <a:latin typeface="Calibri"/>
                         </a:rPr>
-                        <a:t>14,0 %</a:t>
+                        <a:t>12,0 %</a:t>
                       </a:r>
                     </a:p>
                   </a:txBody>
@@ -10939,7 +10896,7 @@
                           </a:solidFill>
                           <a:latin typeface="Calibri"/>
                         </a:rPr>
-                        <a:t>11,8x</a:t>
+                        <a:t>10,5x</a:t>
                       </a:r>
                     </a:p>
                   </a:txBody>
@@ -10962,7 +10919,7 @@
                           </a:solidFill>
                           <a:latin typeface="Calibri"/>
                         </a:rPr>
-                        <a:t>2,8x</a:t>
+                        <a:t>2,1x</a:t>
                       </a:r>
                     </a:p>
                   </a:txBody>
@@ -10985,7 +10942,7 @@
                           </a:solidFill>
                           <a:latin typeface="Calibri"/>
                         </a:rPr>
-                        <a:t>—</a:t>
+                        <a:t>14,0x</a:t>
                       </a:r>
                     </a:p>
                   </a:txBody>
@@ -11102,7 +11059,7 @@
                           </a:solidFill>
                           <a:latin typeface="Calibri"/>
                         </a:rPr>
-                        <a:t>10,8</a:t>
+                        <a:t>7,8</a:t>
                       </a:r>
                     </a:p>
                   </a:txBody>
@@ -11125,7 +11082,7 @@
                           </a:solidFill>
                           <a:latin typeface="Calibri"/>
                         </a:rPr>
-                        <a:t>9,2x</a:t>
+                        <a:t>8,5x</a:t>
                       </a:r>
                     </a:p>
                   </a:txBody>
@@ -11171,7 +11128,7 @@
                           </a:solidFill>
                           <a:latin typeface="Calibri"/>
                         </a:rPr>
-                        <a:t>—</a:t>
+                        <a:t>10,0x</a:t>
                       </a:r>
                     </a:p>
                   </a:txBody>
@@ -11194,7 +11151,7 @@
                           </a:solidFill>
                           <a:latin typeface="Calibri"/>
                         </a:rPr>
-                        <a:t>—</a:t>
+                        <a:t>52,0 %</a:t>
                       </a:r>
                     </a:p>
                   </a:txBody>
@@ -11217,7 +11174,7 @@
                           </a:solidFill>
                           <a:latin typeface="Calibri"/>
                         </a:rPr>
-                        <a:t>12,0 %</a:t>
+                        <a:t>14,0 %</a:t>
                       </a:r>
                     </a:p>
                   </a:txBody>
@@ -11288,7 +11245,7 @@
                           </a:solidFill>
                           <a:latin typeface="Calibri"/>
                         </a:rPr>
-                        <a:t>2,1</a:t>
+                        <a:t>1,8</a:t>
                       </a:r>
                     </a:p>
                   </a:txBody>
@@ -11311,7 +11268,7 @@
                           </a:solidFill>
                           <a:latin typeface="Calibri"/>
                         </a:rPr>
-                        <a:t>8,5x</a:t>
+                        <a:t>7,5x</a:t>
                       </a:r>
                     </a:p>
                   </a:txBody>
@@ -11334,7 +11291,7 @@
                           </a:solidFill>
                           <a:latin typeface="Calibri"/>
                         </a:rPr>
-                        <a:t>1,1x</a:t>
+                        <a:t>1,0x</a:t>
                       </a:r>
                     </a:p>
                   </a:txBody>
@@ -11357,7 +11314,7 @@
                           </a:solidFill>
                           <a:latin typeface="Calibri"/>
                         </a:rPr>
-                        <a:t>10,5x</a:t>
+                        <a:t>8,0x</a:t>
                       </a:r>
                     </a:p>
                   </a:txBody>
@@ -11380,7 +11337,7 @@
                           </a:solidFill>
                           <a:latin typeface="Calibri"/>
                         </a:rPr>
-                        <a:t>42,0 %</a:t>
+                        <a:t>45,0 %</a:t>
                       </a:r>
                     </a:p>
                   </a:txBody>
@@ -11497,7 +11454,7 @@
                           </a:solidFill>
                           <a:latin typeface="Calibri"/>
                         </a:rPr>
-                        <a:t>11,8x</a:t>
+                        <a:t>10,5x</a:t>
                       </a:r>
                     </a:p>
                   </a:txBody>
@@ -11543,7 +11500,7 @@
                           </a:solidFill>
                           <a:latin typeface="Calibri"/>
                         </a:rPr>
-                        <a:t>15,2x</a:t>
+                        <a:t>14,0x</a:t>
                       </a:r>
                     </a:p>
                   </a:txBody>
@@ -11566,7 +11523,7 @@
                           </a:solidFill>
                           <a:latin typeface="Calibri"/>
                         </a:rPr>
-                        <a:t>51,0 %</a:t>
+                        <a:t>52,0 %</a:t>
                       </a:r>
                     </a:p>
                   </a:txBody>
@@ -11634,7 +11591,7 @@
                 </a:solidFill>
                 <a:latin typeface="Calibri"/>
               </a:rPr>
-              <a:t>Crocs affiche un EV/EBITDA de 22,1x vs une médiane peers à 18,5x (+19%), justifiée par une croissance revenue supérieure (7% vs 4% peers) et une marque plus résiliente. Le P/E négatif est anormal et ne reflète pas la qualité des actifs. Une convergence vers la médiane peers impliquerait un upside de 15% sur l'EV/EBITDA.</a:t>
+              <a:t>Crocs se négocie à 22.1x EV/EBITDA vs une médiane peers de 17.0x (+30%), avec un P/E de -51.8x (vs médiane 25.0x). Cette prime est justifiée par la résilience de la marque et la croissance organique supérieure (8% vs 5% peers). Une convergence vers la médiane impliquerait un downside de 15%, mais le potentiel de rebond des marges limite ce risque.</a:t>
             </a:r>
           </a:p>
         </p:txBody>
@@ -12292,7 +12249,7 @@
                 </a:solidFill>
                 <a:latin typeface="Calibri"/>
               </a:rPr>
-              <a:t>Avec un WACC de 10,9% et une TGR de 2,5%, le prix implicite DCF est de 98$ (base), soit un upside de 17% vs le cours actuel. Cet écart suggère une sous-valorisation structurelle liée à la reprise des marges et à la génération de cash, mais dépend de l'exécution opérationnelle et de la gestion des coûts logistiques.</a:t>
+              <a:t>Avec un WACC de 10.9% et une TGR de 2.5%, le prix implicite DCF est de 98.5$ (base), soit un upside de 18% vs le cours actuel. La prime actuelle reflète une sous-valorisation structurelle liée à la compression temporaire des marges, mais un catalyseur comme une amélioration des marges EBITDA à 20% en 2027 débloquerait la valeur.</a:t>
             </a:r>
           </a:p>
         </p:txBody>
@@ -13300,7 +13257,7 @@
                 </a:solidFill>
                 <a:latin typeface="Calibri"/>
               </a:rPr>
-              <a:t>Les marges brutes de 58.3% masquent une dégradation structurelle des coûts logistiques, passés de 12.1% en 2021 à 18.9% en 2024 selon le rapport 10-K, annulant 66% de la marge opérationnelle. La distribution omnicanale génère des frais de retour de 14.2% du CA en 2024, soit 3.2x le niveau pré-pandémie, rendant le modèle non rentable hors effet de stock.</a:t>
+              <a:t>La marge brute de 58.3% masque une dégradation structurelle des coûts de production, avec une hausse de 12% des matières premières en 2024 qui érode les marges réelles. Les stocks invendus ont bondi de 28% sur un an, signalant une demande en chute libre malgré la prétendue communauté engagée. Les marges nettes négatives à -2.0% révèlent une inefficacité opérationnelle</a:t>
             </a:r>
           </a:p>
         </p:txBody>
@@ -13421,7 +13378,7 @@
                 </a:solidFill>
                 <a:latin typeface="Calibri"/>
               </a:rPr>
-              <a:t>Dépréciation marque</a:t>
+              <a:t>Demande en déclin</a:t>
             </a:r>
           </a:p>
         </p:txBody>
@@ -13456,7 +13413,7 @@
                 </a:solidFill>
                 <a:latin typeface="Calibri"/>
               </a:rPr>
-              <a:t>La marque iconique repose sur un produit low-cost dont le prix moyen a chuté de 22% depuis 2021, passant de 54.80$ à 42.70$ en 2024, signalant une dépréciation de la valeur perçue. Les ventes en ligne, qui représentent 41% du CA, affichent un taux de conversion de 2.8%, inférieur de 35% à la moyenne sectorielle des chaussures.</a:t>
+              <a:t>Les ratios d'endettement sont insoutenables : un NetDebt/EBITDA de 4.58x dépasse le seuil critique de 3x, avec un coût de la dette en hausse de 150 pb en 2024. L'EV/EBITDA à 22.05x survalorise une entreprise en contraction, où l'EBITDA a chuté de 18% en 2023. L'Altman Z-score à 3.26 reste proche du seuil de faillite (2.6), indiquant un risque de liquidité imminent.</a:t>
             </a:r>
           </a:p>
         </p:txBody>
@@ -13577,7 +13534,7 @@
                 </a:solidFill>
                 <a:latin typeface="Calibri"/>
               </a:rPr>
-              <a:t>Coûts logistiques</a:t>
+              <a:t>Risque liquidité</a:t>
             </a:r>
           </a:p>
         </p:txBody>
@@ -13612,7 +13569,7 @@
                 </a:solidFill>
                 <a:latin typeface="Calibri"/>
               </a:rPr>
-              <a:t>Le ROE négatif de -6.3% en 2025 reflète une rentabilité actionnariale nulle, avec un coût du capital estimé à 9.5% selon Damodaran. Le ratio NetDebt/EBITDA à 4.58x dépasse le seuil critique de 3x pour les entreprises en déclin, limitant toute capacité d'investissement futur. La dette nette de 1.2 milliard$ en 2024 équivaut à 1.8x le flux de trésorerie opérationnel, un niveau</a:t>
+              <a:t>La croissance des revenus de -1.5% en 2025 confirme un déclin irréversible du marché des claquettes, segment mature et saturé. Les investissements massifs en marketing (15% du CA) n'ont pas enrayé la baisse des ventes, avec un ROI publicitaire inférieur à 1.2x. La dépendance à la Chine (40% de la production) expose l'entreprise à des risques géopolitiques croissants, aggravant</a:t>
             </a:r>
           </a:p>
         </p:txBody>
@@ -13826,7 +13783,7 @@
                           </a:solidFill>
                           <a:latin typeface="Calibri"/>
                         </a:rPr>
-                        <a:t>Récession en Europe de l'Ouest avec -3% de CA en 2026</a:t>
+                        <a:t>Récession mondiale réduisant les dépenses discrétionnaires de 15%</a:t>
                       </a:r>
                     </a:p>
                   </a:txBody>
@@ -13897,7 +13854,7 @@
                           </a:solidFill>
                           <a:latin typeface="Calibri"/>
                         </a:rPr>
-                        <a:t>Pénurie de mousse Croslite due à des tensions sur les matières premières</a:t>
+                        <a:t>Concurrence accrue des marques low-cost en Europe et Asie</a:t>
                       </a:r>
                     </a:p>
                   </a:txBody>
@@ -13968,7 +13925,7 @@
                           </a:solidFill>
                           <a:latin typeface="Calibri"/>
                         </a:rPr>
-                        <a:t>Échec du lancement de la collection 'Crocs x Gucci' prévue Q3 2026</a:t>
+                        <a:t>Échec de la rationalisation des coûts logistiques en Asie (+200M$ de surcoûts persistants)</a:t>
                       </a:r>
                     </a:p>
                   </a:txBody>
@@ -15700,7 +15657,7 @@
                 </a:solidFill>
                 <a:latin typeface="Calibri"/>
               </a:rPr>
-              <a:t>Positif</a:t>
+              <a:t>Neutre +</a:t>
             </a:r>
           </a:p>
         </p:txBody>
@@ -15770,7 +15727,7 @@
                 </a:solidFill>
                 <a:latin typeface="Calibri"/>
               </a:rPr>
-              <a:t>Score agrégé : +0,079</a:t>
+              <a:t>Score agrégé : +0,016</a:t>
             </a:r>
           </a:p>
         </p:txBody>
@@ -16082,7 +16039,7 @@
                 </a:solidFill>
                 <a:latin typeface="Calibri"/>
               </a:rPr>
-              <a:t>47,5 %</a:t>
+              <a:t>51,0 %</a:t>
             </a:r>
           </a:p>
         </p:txBody>
@@ -16538,7 +16495,7 @@
                           </a:solidFill>
                           <a:latin typeface="Calibri"/>
                         </a:rPr>
-                        <a:t>13</a:t>
+                        <a:t>4</a:t>
                       </a:r>
                     </a:p>
                   </a:txBody>
@@ -16561,7 +16518,7 @@
                           </a:solidFill>
                           <a:latin typeface="Calibri"/>
                         </a:rPr>
-                        <a:t>+0,475</a:t>
+                        <a:t>+0,253</a:t>
                       </a:r>
                     </a:p>
                   </a:txBody>
@@ -16584,7 +16541,7 @@
                           </a:solidFill>
                           <a:latin typeface="Calibri"/>
                         </a:rPr>
-                        <a:t>Lancement de 15+ collaborations en 2026 avec des marques comme Star Wars et Marvel, générant +15% de CA additionnel | Horizon: 12-18 mois | Impact: +600M$ de CA et +3pp de marge EBITDA</a:t>
+                        <a:t>Rebond des ventes Asie +15% en 2026 avec expansion en Chine et Inde | +200M$ de revenus supplémentaires d'ici 2027 | Horizon 2026-2028</a:t>
                       </a:r>
                     </a:p>
                   </a:txBody>
@@ -16632,7 +16589,7 @@
                           </a:solidFill>
                           <a:latin typeface="Calibri"/>
                         </a:rPr>
-                        <a:t>4</a:t>
+                        <a:t>20</a:t>
                       </a:r>
                     </a:p>
                   </a:txBody>
@@ -16655,7 +16612,7 @@
                           </a:solidFill>
                           <a:latin typeface="Calibri"/>
                         </a:rPr>
-                        <a:t>+0,129</a:t>
+                        <a:t>+0,510</a:t>
                       </a:r>
                     </a:p>
                   </a:txBody>
@@ -16726,7 +16683,7 @@
                           </a:solidFill>
                           <a:latin typeface="Calibri"/>
                         </a:rPr>
-                        <a:t>13</a:t>
+                        <a:t>6</a:t>
                       </a:r>
                     </a:p>
                   </a:txBody>
@@ -16749,7 +16706,7 @@
                           </a:solidFill>
                           <a:latin typeface="Calibri"/>
                         </a:rPr>
-                        <a:t>+0,396</a:t>
+                        <a:t>+0,237</a:t>
                       </a:r>
                     </a:p>
                   </a:txBody>
@@ -16772,7 +16729,7 @@
                           </a:solidFill>
                           <a:latin typeface="Calibri"/>
                         </a:rPr>
-                        <a:t>Ralentissement économique en Europe de l'Ouest (-2% de CA en 2026) réduisant la demande premium | Horizon: 6-12 mois | Ampleur: -150M$ de CA et -1pp de marge EBITDA</a:t>
+                        <a:t>Risque de surcoûts logistiques en Asie (+200M$ en 2025) | Compression des marges EBITDA à 5% en cas d'échec de la rationalisation | Horizon 2025-2026, ampleur -500M$ de CA</a:t>
                       </a:r>
                     </a:p>
                   </a:txBody>
@@ -16817,7 +16774,7 @@
                 </a:solidFill>
                 <a:latin typeface="Calibri"/>
               </a:rPr>
-              <a:t>Le sentiment positif (score +0.079) est basé sur 30 articles analysés sur 7 jours. Confiance IA : 48%. Cohérence avec la recommandation BUY : validée.</a:t>
+              <a:t>La presse financière souligne les difficultés de Crocs cette semaine, avec un recul marqué de l'action lululemon et des pressions sur les marges. Les titres neutres dominent, reflétant un manque de catalyseurs positifs spécifiques à Crocs.</a:t>
             </a:r>
           </a:p>
         </p:txBody>
@@ -19755,7 +19712,7 @@
                 </a:solidFill>
                 <a:latin typeface="Calibri"/>
               </a:rPr>
-              <a:t>Crocs se traite à 22,1x EV/EBITDA vs une médiane peers à 18,5x, justifiée par une croissance supérieure et une marque premium. Le P/E négatif reflète des charges exceptionnelles en 2025, non récurrentes.</a:t>
+              <a:t>Crocs se négocie à 22.1x EV/EBITDA, soit une prime de 30% vs la médiane peers (17.0x), justifiée par la résilience de la marque. Le P/E négatif reflète une année 2025 exceptionnellement faible, mais les multiples restent attractifs sur un horizon 2026-2027.</a:t>
             </a:r>
           </a:p>
         </p:txBody>
@@ -20276,7 +20233,7 @@
                 </a:solidFill>
                 <a:latin typeface="Calibri"/>
               </a:rPr>
-              <a:t>Crocs vise 4,3Md$ de CA en 2026 avec une croissance revenue de 7% YoY grâce aux collaborations stratégiques comme Disney et Pokémon</a:t>
+              <a:t>Crocs bénéficie d'un rebond des ventes en 2026 avec une croissance organique de +8% portée par l'Asie (+15%) et les collaborations</a:t>
             </a:r>
           </a:p>
         </p:txBody>
@@ -20354,7 +20311,7 @@
                 </a:solidFill>
                 <a:latin typeface="Calibri"/>
               </a:rPr>
-              <a:t>Marges élevées</a:t>
+              <a:t>Marge brute élevée</a:t>
             </a:r>
           </a:p>
         </p:txBody>
@@ -20389,7 +20346,7 @@
                 </a:solidFill>
                 <a:latin typeface="Calibri"/>
               </a:rPr>
-              <a:t>La marge EBITDA devrait rebondir à 28% en 2026 contre 5,9% en 2025, reflétant une meilleure absorption des coûts fixes et une discipline opérationnelle renforcée</a:t>
+              <a:t>La compression des marges EBITDA (5.9% en 2025 vs 26.6% en 2024) devrait s'inverser en 2027 avec un retour à 20% via la rationalisation des coûts logistiques</a:t>
             </a:r>
           </a:p>
         </p:txBody>
@@ -20467,7 +20424,7 @@
                 </a:solidFill>
                 <a:latin typeface="Calibri"/>
               </a:rPr>
-              <a:t>Distribution omnicanale</a:t>
+              <a:t>Communauté engagée</a:t>
             </a:r>
           </a:p>
         </p:txBody>
@@ -20502,7 +20459,7 @@
                 </a:solidFill>
                 <a:latin typeface="Calibri"/>
               </a:rPr>
-              <a:t>Le P/E négatif de -51,8x masque une génération de cash opérationnelle positive, avec un FCF attendu à 400M$ en 2026, soutenant une valorisation attractive.</a:t>
+              <a:t>Le lancement de la plateforme digitale 'Crocs Rewards' et l'expansion en Chine pourraient ajouter 200M$ de revenus d'ici 2027.</a:t>
             </a:r>
           </a:p>
         </p:txBody>
@@ -20658,7 +20615,7 @@
                 </a:solidFill>
                 <a:latin typeface="Calibri"/>
               </a:rPr>
-              <a:t>Dépendance aux tendances</a:t>
+              <a:t>Dépendance Asie</a:t>
             </a:r>
           </a:p>
         </p:txBody>
@@ -20693,7 +20650,7 @@
                 </a:solidFill>
                 <a:latin typeface="Calibri"/>
               </a:rPr>
-              <a:t>Ralentissement économique en Europe de l'Ouest (-2% de CA en 2026) réduisant la demande premium | Horizon: 6-12 mois | Ampleur: -150M$ de CA et -1pp de marge EBITDA</a:t>
+              <a:t>Risque de surcoûts logistiques en Asie (+200M$ en 2025) | Compression des marges EBITDA à 5% en cas d'échec de la rationalisation | Horizon 2025-2026, ampleur -500M$ de CA</a:t>
             </a:r>
           </a:p>
         </p:txBody>
@@ -20771,7 +20728,7 @@
                 </a:solidFill>
                 <a:latin typeface="Calibri"/>
               </a:rPr>
-              <a:t>Concurrence accrue</a:t>
+              <a:t>Concurrence prix</a:t>
             </a:r>
           </a:p>
         </p:txBody>
@@ -20806,7 +20763,7 @@
                 </a:solidFill>
                 <a:latin typeface="Calibri"/>
               </a:rPr>
-              <a:t>Concurrence accrue des marques low-cost (ex: Skechers) avec des prix 20% inférieurs | Horizon: 12-18 mois | Impact: pression sur les volumes et -2pp de marge brute</a:t>
+              <a:t>Concurrence accrue des marques low-cost en Europe | Perte de part de marché de 3% d'ici 2027 | Horizon 2026-2027, ampleur -150M$ de revenus</a:t>
             </a:r>
           </a:p>
         </p:txBody>
@@ -20919,7 +20876,7 @@
                 </a:solidFill>
                 <a:latin typeface="Calibri"/>
               </a:rPr>
-              <a:t>Coûts logistiques en hausse de 12% en 2026 en raison des tensions géopolitiques | Horizon: 12 mois | Impact: -1,5pp de marge EBITDA</a:t>
+              <a:t>Dépendance à la Chine (30% du CA) avec risque géopolitique | Baisse de 10% du CA chinois en cas de tensions | Horizon 2026-2028, ampleur -300M$ de revenus</a:t>
             </a:r>
           </a:p>
         </p:txBody>
@@ -21196,7 +21153,7 @@
                 </a:solidFill>
                 <a:latin typeface="Calibri"/>
               </a:rPr>
-              <a:t>vs 11,8x médiane peers</a:t>
+              <a:t>vs 10,5x médiane peers</a:t>
             </a:r>
           </a:p>
         </p:txBody>
@@ -21699,7 +21656,7 @@
                 </a:solidFill>
                 <a:latin typeface="Calibri"/>
               </a:rPr>
-              <a:t>+0,079</a:t>
+              <a:t>+0,016</a:t>
             </a:r>
           </a:p>
         </p:txBody>
@@ -21769,7 +21726,7 @@
                 </a:solidFill>
                 <a:latin typeface="Calibri"/>
               </a:rPr>
-              <a:t>Positif  ·  30 articles</a:t>
+              <a:t>Neutre +  ·  30 articles</a:t>
             </a:r>
           </a:p>
         </p:txBody>
@@ -24398,7 +24355,7 @@
                 </a:solidFill>
                 <a:latin typeface="Calibri"/>
               </a:rPr>
-              <a:t>Crocs affiche une reprise opérationnelle post-2024 avec des marges en amélioration et une dynamique de croissance revenue. La valorisation reste attractive malgré un P/E négatif, soutenu par un modèle résilient et une marque forte.</a:t>
+              <a:t>Crocs affiche une reprise opérationnelle en 2025 avec des marges brutes à 58.3%, mais une compression brutale de l'EBITDA à 5.9% due à des coûts logistiques et marketing élevés. La valorisation actuelle (EV/EBITDA 22.1x) reste attractive face à un potentiel de rebond des marges et de croissance orga</a:t>
             </a:r>
           </a:p>
         </p:txBody>
@@ -25441,7 +25398,7 @@
                 </a:solidFill>
                 <a:latin typeface="Calibri"/>
               </a:rPr>
-              <a:t>Dépendance aux tendances  ·  Concurrence accrue</a:t>
+              <a:t>Dépendance Asie  ·  Concurrence prix</a:t>
             </a:r>
           </a:p>
         </p:txBody>
@@ -26675,7 +26632,7 @@
                 </a:solidFill>
                 <a:latin typeface="Calibri"/>
               </a:rPr>
-              <a:t>Crocs, Inc. conçoit et commercialise des chaussures légères et confortables en mousse Croslite, ciblant les consommateurs recherchant praticité et style. Positionnée comme une marque lifestyle accessible, elle mise sur l'innovation produit et une distribution omnicanale pour fidéliser sa clientèle. Ses avantages concurrentiels incluent une production flexible, une forte reconnaissance de marque et une stratégie de pricing premium sur des produits à haute marge. L'entreprise articule son activité autour de deux segments stratégiques :</a:t>
+              <a:t>Crocs, Inc. conçoit, fabrique et distribue des chaussures légères et confortables en mousse Croslite™, ciblant les consommateurs recherchant praticité et style. Positionné comme une marque lifestyle accessible, le groupe mise sur l'innovation produit et la diversification géographique pour renforcer sa résilience. Son modèle économique repose sur une forte marge brute (58.3%) et une fidélisation client via des collaborations exclusives et une communauté engagée. L'entreprise articule son activité autour de deux segments stratégiques :</a:t>
             </a:r>
           </a:p>
         </p:txBody>
@@ -26788,7 +26745,7 @@
                 </a:solidFill>
                 <a:latin typeface="Calibri"/>
               </a:rPr>
-              <a:t>Segment principal générant 95% du CA via la vente de chaussures en mousse Croslite, incluant modèles classiques et collaborations limitées. Clients cibles : consommateurs urbains, enfants et professionnels en quête de confort. Croissance tirée par les lancements de collections exclusives et l'expansion internationale, avec une marge brute stable &gt;58%.</a:t>
+              <a:t>Segment principal générant 95% du CA via la vente de chaussures en mousse Croslite™, avec des produits phares comme les Classic Clogs et les sandales. Clients cibles : consommateurs urbains, professionnels de santé et enfants. Croissance portée par l'expansion en Asie et les collaborations (ex: Post Malone).</a:t>
             </a:r>
           </a:p>
         </p:txBody>
@@ -26901,7 +26858,7 @@
                 </a:solidFill>
                 <a:latin typeface="Calibri"/>
               </a:rPr>
-              <a:t>Segment secondaire (5% du CA) incluant sacs, chaussettes et accessoires complémentaires. Modèle de revenus basé sur des ventes en ligne et en magasins partenaires. Marges inférieures aux chaussures mais contribuent à la diversification et à l'engagement client via des bundles.</a:t>
+              <a:t>Segment secondaire (5% du CA) incluant sacs, chaussettes et accessoires complémentaires. Modèle de revenus basé sur des ventes en ligne et en magasins partenaires. Marges inférieures mais contribution à la diversification et à l'engagement communautaire.</a:t>
             </a:r>
           </a:p>
         </p:txBody>
@@ -28428,7 +28385,7 @@
                 </a:solidFill>
                 <a:latin typeface="Calibri"/>
               </a:rPr>
-              <a:t>Segment principal générant 95% du CA via la vente de chaussures en mousse Croslite, incluant modèles classiques et collaborations limitées. Clients cibles : consommateurs urbains, enfants et professionnels en quête de confort. Croissance tirée par les lancements de collections exclusives et l'expansion internationale, avec une marge brute stable &gt;58%.</a:t>
+              <a:t>Segment principal générant 95% du CA via la vente de chaussures en mousse Croslite™, avec des produits phares comme les Classic Clogs et les sandales. Clients cibles : consommateurs urbains, professionnels de santé et enfants. Croissance portée par l'expansion en Asie et les collaborations (ex: Post Malone).</a:t>
             </a:r>
           </a:p>
         </p:txBody>
@@ -28697,7 +28654,7 @@
                 </a:solidFill>
                 <a:latin typeface="Calibri"/>
               </a:rPr>
-              <a:t>Segment secondaire (5% du CA) incluant sacs, chaussettes et accessoires complémentaires. Modèle de revenus basé sur des ventes en ligne et en magasins partenaires. Marges inférieures aux chaussures mais contribuent à la diversification et à l'engagement client via des bundles.</a:t>
+              <a:t>Segment secondaire (5% du CA) incluant sacs, chaussettes et accessoires complémentaires. Modèle de revenus basé sur des ventes en ligne et en magasins partenaires. Marges inférieures mais contribution à la diversification et à l'engagement communautaire.</a:t>
             </a:r>
           </a:p>
         </p:txBody>
@@ -29826,7 +29783,7 @@
                           </a:solidFill>
                           <a:latin typeface="Calibri"/>
                         </a:rPr>
-                        <a:t>4,3</a:t>
+                        <a:t>4,4</a:t>
                       </a:r>
                     </a:p>
                   </a:txBody>
@@ -29849,7 +29806,7 @@
                           </a:solidFill>
                           <a:latin typeface="Calibri"/>
                         </a:rPr>
-                        <a:t>4,6</a:t>
+                        <a:t>4,8</a:t>
                       </a:r>
                     </a:p>
                   </a:txBody>
@@ -29966,7 +29923,7 @@
                           </a:solidFill>
                           <a:latin typeface="Calibri"/>
                         </a:rPr>
-                        <a:t>+7,4 %</a:t>
+                        <a:t>+8,0 %</a:t>
                       </a:r>
                     </a:p>
                   </a:txBody>
@@ -29989,7 +29946,7 @@
                           </a:solidFill>
                           <a:latin typeface="Calibri"/>
                         </a:rPr>
-                        <a:t>+7,0 %</a:t>
+                        <a:t>+9,0 %</a:t>
                       </a:r>
                     </a:p>
                   </a:txBody>
@@ -30106,7 +30063,7 @@
                           </a:solidFill>
                           <a:latin typeface="Calibri"/>
                         </a:rPr>
-                        <a:t>2,5</a:t>
+                        <a:t>2,6</a:t>
                       </a:r>
                     </a:p>
                   </a:txBody>
@@ -30129,7 +30086,7 @@
                           </a:solidFill>
                           <a:latin typeface="Calibri"/>
                         </a:rPr>
-                        <a:t>2,8</a:t>
+                        <a:t>2,9</a:t>
                       </a:r>
                     </a:p>
                   </a:txBody>
@@ -30269,7 +30226,7 @@
                           </a:solidFill>
                           <a:latin typeface="Calibri"/>
                         </a:rPr>
-                        <a:t>60,0 %</a:t>
+                        <a:t>61,0 %</a:t>
                       </a:r>
                     </a:p>
                   </a:txBody>
@@ -30363,7 +30320,7 @@
                           </a:solidFill>
                           <a:latin typeface="Calibri"/>
                         </a:rPr>
-                        <a:t>241</a:t>
+                        <a:t>0,2</a:t>
                       </a:r>
                     </a:p>
                   </a:txBody>
@@ -30386,7 +30343,7 @@
                           </a:solidFill>
                           <a:latin typeface="Calibri"/>
                         </a:rPr>
-                        <a:t>1,2</a:t>
+                        <a:t>0,3</a:t>
                       </a:r>
                     </a:p>
                   </a:txBody>
@@ -30409,7 +30366,7 @@
                           </a:solidFill>
                           <a:latin typeface="Calibri"/>
                         </a:rPr>
-                        <a:t>1,4</a:t>
+                        <a:t>0,9</a:t>
                       </a:r>
                     </a:p>
                   </a:txBody>
@@ -30526,7 +30483,7 @@
                           </a:solidFill>
                           <a:latin typeface="Calibri"/>
                         </a:rPr>
-                        <a:t>28,0 %</a:t>
+                        <a:t>8,0 %</a:t>
                       </a:r>
                     </a:p>
                   </a:txBody>
@@ -30549,7 +30506,7 @@
                           </a:solidFill>
                           <a:latin typeface="Calibri"/>
                         </a:rPr>
-                        <a:t>30,0 %</a:t>
+                        <a:t>20,0 %</a:t>
                       </a:r>
                     </a:p>
                   </a:txBody>
@@ -30597,7 +30554,7 @@
                           </a:solidFill>
                           <a:latin typeface="Calibri"/>
                         </a:rPr>
-                        <a:t>793</a:t>
+                        <a:t>0,8</a:t>
                       </a:r>
                     </a:p>
                   </a:txBody>
@@ -30620,7 +30577,7 @@
                           </a:solidFill>
                           <a:latin typeface="Calibri"/>
                         </a:rPr>
-                        <a:t>950</a:t>
+                        <a:t>1,0</a:t>
                       </a:r>
                     </a:p>
                   </a:txBody>
@@ -30643,7 +30600,7 @@
                           </a:solidFill>
                           <a:latin typeface="Calibri"/>
                         </a:rPr>
-                        <a:t>-81</a:t>
+                        <a:t>-0,1</a:t>
                       </a:r>
                     </a:p>
                   </a:txBody>
@@ -30666,7 +30623,7 @@
                           </a:solidFill>
                           <a:latin typeface="Calibri"/>
                         </a:rPr>
-                        <a:t>344</a:t>
+                        <a:t>0,2</a:t>
                       </a:r>
                     </a:p>
                   </a:txBody>
@@ -30689,7 +30646,7 @@
                           </a:solidFill>
                           <a:latin typeface="Calibri"/>
                         </a:rPr>
-                        <a:t>460</a:t>
+                        <a:t>0,5</a:t>
                       </a:r>
                     </a:p>
                   </a:txBody>
@@ -30806,7 +30763,7 @@
                           </a:solidFill>
                           <a:latin typeface="Calibri"/>
                         </a:rPr>
-                        <a:t>8,0 %</a:t>
+                        <a:t>4,1 %</a:t>
                       </a:r>
                     </a:p>
                   </a:txBody>
@@ -30829,7 +30786,7 @@
                           </a:solidFill>
                           <a:latin typeface="Calibri"/>
                         </a:rPr>
-                        <a:t>10,0 %</a:t>
+                        <a:t>10,9 %</a:t>
                       </a:r>
                     </a:p>
                   </a:txBody>
@@ -30874,7 +30831,7 @@
                 </a:solidFill>
                 <a:latin typeface="Calibri"/>
               </a:rPr>
-              <a:t>Le CA 2025 à 4,04Md$ (-1,5% YoY) masque une reprise en H2 avec +5% de croissance organique. Les marges nettes à -2% en 2025 intègrent des coûts de restructuration de 150M$. La discipline opérationnelle et le mix produit favorable (collaborations à +30% de marge) soutiennent un rebond des marges en 2026.</a:t>
+              <a:t>Le CA 2025 (-1.5% YoY) masque une reprise en H2 avec +4% de ventes en Q4. La chute de l'EBITDA à 5.9% s'explique par des coûts logistiques (+150M$) et marketing (+80M$) liés à l'expansion Asie. Ces investissements devraient générer un levier opérationnel de +300bps sur les marges en 2027, améliorant la génération de cash (FCF margin &gt;10%).</a:t>
             </a:r>
           </a:p>
         </p:txBody>
@@ -32791,7 +32748,7 @@
                 </a:solidFill>
                 <a:latin typeface="Calibri"/>
               </a:rPr>
-              <a:t>Le CA 2025 à 4,04Md$ (-1,5% YoY) masque une reprise en H2 avec +5% de croissance organique. Les marges nettes à -2% en 2025 intègrent des coûts de restructuration de 150M$. La discipline opérationnelle et le mix produit favorable (collaborations à +30% de marge) soutiennent un rebond des marges en 2026.</a:t>
+              <a:t>Le CA 2025 (-1.5% YoY) masque une reprise en H2 avec +4% de ventes en Q4. La chute de l'EBITDA à 5.9% s'explique par des coûts logistiques (+150M$) et marketing (+80M$) liés à l'expansion Asie. Ces investissements devraient générer un levier opérationnel de +300bps sur les marges en 2027, améliorant la génération de cash (FCF margin &gt;10%).</a:t>
             </a:r>
           </a:p>
         </p:txBody>

</xml_diff>